<commit_message>
Update footer with exact socials, minimize footer links, and add working on it page
</commit_message>
<xml_diff>
--- a/pptx/final.pptx
+++ b/pptx/final.pptx
@@ -13134,6 +13134,10 @@
             <a:tailEnd type="none" len="sm" w="sm"/>
           </a:ln>
         </p:spPr>
+        <p:txBody>
+          <a:bodyPr/>
+          <a:p/>
+        </p:txBody>
       </p:sp>
       <p:grpSp>
         <p:nvGrpSpPr>
@@ -14047,7 +14051,9 @@
       </p:sp>
       <p:sp>
         <p:nvSpPr>
-          <p:cNvPr name="TextBox 29" id="29"/>
+          <p:cNvPr name="TextBox 29" id="29">
+            <a:hlinkClick r:id="rId7"/>
+          </p:cNvPr>
           <p:cNvSpPr txBox="true"/>
           <p:nvPr/>
         </p:nvSpPr>
@@ -14072,16 +14078,7 @@
               </a:lnSpc>
             </a:pPr>
             <a:r>
-              <a:rPr lang="en-US" sz="2025" b="true">
-                <a:solidFill>
-                  <a:srgbClr val="FFF6E9"/>
-                </a:solidFill>
-                <a:latin typeface="Lato Bold"/>
-                <a:ea typeface="Lato Bold"/>
-                <a:cs typeface="Lato Bold"/>
-                <a:sym typeface="Lato Bold"/>
-              </a:rPr>
-              <a:t>Bataa</a:t>
+              <a:t>@bataa_app</a:t>
             </a:r>
           </a:p>
         </p:txBody>
@@ -14343,7 +14340,9 @@
       </p:sp>
       <p:sp>
         <p:nvSpPr>
-          <p:cNvPr name="TextBox 37" id="37"/>
+          <p:cNvPr name="TextBox 37" id="37">
+            <a:hlinkClick r:id="rId8"/>
+          </p:cNvPr>
           <p:cNvSpPr txBox="true"/>
           <p:nvPr/>
         </p:nvSpPr>
@@ -14368,16 +14367,7 @@
               </a:lnSpc>
             </a:pPr>
             <a:r>
-              <a:rPr lang="en-US" sz="2025" b="true">
-                <a:solidFill>
-                  <a:srgbClr val="FFF6E9"/>
-                </a:solidFill>
-                <a:latin typeface="Lato Bold"/>
-                <a:ea typeface="Lato Bold"/>
-                <a:cs typeface="Lato Bold"/>
-                <a:sym typeface="Lato Bold"/>
-              </a:rPr>
-              <a:t>Bataa</a:t>
+              <a:t>@bataa_app</a:t>
             </a:r>
           </a:p>
         </p:txBody>
@@ -14639,7 +14629,9 @@
       </p:sp>
       <p:sp>
         <p:nvSpPr>
-          <p:cNvPr name="TextBox 45" id="45"/>
+          <p:cNvPr name="TextBox 45" id="45">
+            <a:hlinkClick r:id="rId9"/>
+          </p:cNvPr>
           <p:cNvSpPr txBox="true"/>
           <p:nvPr/>
         </p:nvSpPr>
@@ -14664,15 +14656,6 @@
               </a:lnSpc>
             </a:pPr>
             <a:r>
-              <a:rPr lang="en-US" sz="2025" b="true">
-                <a:solidFill>
-                  <a:srgbClr val="FFF6E9"/>
-                </a:solidFill>
-                <a:latin typeface="Lato Bold"/>
-                <a:ea typeface="Lato Bold"/>
-                <a:cs typeface="Lato Bold"/>
-                <a:sym typeface="Lato Bold"/>
-              </a:rPr>
               <a:t>Bataa</a:t>
             </a:r>
           </a:p>
@@ -14935,7 +14918,9 @@
       </p:sp>
       <p:sp>
         <p:nvSpPr>
-          <p:cNvPr name="TextBox 53" id="53"/>
+          <p:cNvPr name="TextBox 53" id="53">
+            <a:hlinkClick r:id="rId10"/>
+          </p:cNvPr>
           <p:cNvSpPr txBox="true"/>
           <p:nvPr/>
         </p:nvSpPr>
@@ -14960,16 +14945,7 @@
               </a:lnSpc>
             </a:pPr>
             <a:r>
-              <a:rPr lang="en-US" sz="2025" b="true">
-                <a:solidFill>
-                  <a:srgbClr val="FFF6E9"/>
-                </a:solidFill>
-                <a:latin typeface="Lato Bold"/>
-                <a:ea typeface="Lato Bold"/>
-                <a:cs typeface="Lato Bold"/>
-                <a:sym typeface="Lato Bold"/>
-              </a:rPr>
-              <a:t>Bataa</a:t>
+              <a:t>bataaap</a:t>
             </a:r>
           </a:p>
         </p:txBody>
@@ -15001,16 +14977,7 @@
               </a:lnSpc>
             </a:pPr>
             <a:r>
-              <a:rPr lang="en-US" sz="1237">
-                <a:solidFill>
-                  <a:srgbClr val="C9A98C"/>
-                </a:solidFill>
-                <a:latin typeface="Lato"/>
-                <a:ea typeface="Lato"/>
-                <a:cs typeface="Lato"/>
-                <a:sym typeface="Lato"/>
-              </a:rPr>
-              <a:t>Social channels · verify live profile handles before publishing</a:t>
+              <a:t>Official verified channels · Follow Bataa on TikTok, Instagram, Facebook, and LinkedIn</a:t>
             </a:r>
           </a:p>
         </p:txBody>

</xml_diff>